<commit_message>
feat: show the ride flow on a live Belo Horizonte map
Point the load and failure scripts at the city graph, keep the routing outage visible on the dashboard, and leave the small fixture for tests.

Co-authored-by: Cursor <cursoragent@cursor.com>
</commit_message>
<xml_diff>
--- a/slides/nearby-drivers.pptx
+++ b/slides/nearby-drivers.pptx
@@ -797,7 +797,7 @@
           <a:lstStyle/>
           <a:p>
             <a:r>
-              <a:t>nginx na porta 8080 para rides e drivers. Routing só na rede interna, porta 8081, com health check em readyz. Kafka: rides por 7 dias, localização por 5 minutos, presença por 1 hora. Redis sem persistência: só TTL. Postgres 17 com schemas ride e driver separados.</a:t>
+              <a:t>No cluster: ride 1, driver 1, matching de 1 a 3, routing de 2 a 4. O autoscaler olha 60% de CPU e sobe um pod a cada 30 segundos. Kafka: rides por 7 dias, localização por 5 minutos, presença por 1 hora. Redis sem persistência: só TTL. Postgres 17 com schemas ride e driver separados.</a:t>
             </a:r>
           </a:p>
         </p:txBody>
@@ -867,7 +867,7 @@
           <a:lstStyle/>
           <a:p>
             <a:r>
-              <a:t>Ride, driver e matching: uma instância. O índice espacial do driver vive naquele processo. Routing: duas réplicas stateless. Redis guarda idempotência por 24 h, reserva por 30 s, última posição por 60 s e dedup de evento por 1 h. Nada disso é a garantia final.</a:t>
+              <a:t>Ride e driver: uma instância. O índice espacial do driver vive naquele processo. Matching de 1 a 3, uma cópia por partição do pedido. Routing de 2 a 4, sem estado. Redis guarda idempotência por 24 h, reserva por 30 s, última posição por 60 s e dedup de evento por 1 h. Nada disso é a garantia final.</a:t>
             </a:r>
           </a:p>
         </p:txBody>
@@ -1147,7 +1147,7 @@
           <a:lstStyle/>
           <a:p>
             <a:r>
-              <a:t>Ride é a dona do estado. Driver responde quem está perto. Matching só monta o ranking. Routing só devolve tempo e distância. Ride, driver e matching têm uma instância. Routing tem duas, porque não guarda estado.</a:t>
+              <a:t>Ride é a dona do estado. Driver responde quem está perto. Matching só monta o ranking. Routing só devolve tempo e distância. Ride e driver ficam em uma instância: cada um guarda estado. Matching sobe de 1 a 3 e routing de 2 a 4 quando a CPU passa de 60%.</a:t>
             </a:r>
           </a:p>
         </p:txBody>
@@ -6750,7 +6750,7 @@
                 </a:solidFill>
                 <a:latin typeface="Georgia"/>
               </a:rPr>
-              <a:t>Duas réplicas</a:t>
+              <a:t>Cresce com a CPU</a:t>
             </a:r>
           </a:p>
         </p:txBody>
@@ -6790,7 +6790,7 @@
                 </a:solidFill>
                 <a:latin typeface="Arial"/>
               </a:rPr>
-              <a:t>Não há estado para sincronizar. O nginx manda a busca para quem está pronto.</a:t>
+              <a:t>Começa em duas e vai até quatro. Não há estado para copiar entre elas.</a:t>
             </a:r>
           </a:p>
         </p:txBody>
@@ -6920,7 +6920,7 @@
                 </a:solidFill>
                 <a:latin typeface="Georgia"/>
               </a:rPr>
-              <a:t>Se lotar, tenta a outra</a:t>
+              <a:t>Se lotar, tenta de novo</a:t>
             </a:r>
           </a:p>
         </p:txBody>
@@ -6960,7 +6960,7 @@
                 </a:solidFill>
                 <a:latin typeface="Arial"/>
               </a:rPr>
-              <a:t>Há um limite de buscas ao mesmo tempo. Passou disso, a outra réplica assume.</a:t>
+              <a:t>Há um limite de buscas ao mesmo tempo. A réplica cheia pede para tentar outra.</a:t>
             </a:r>
           </a:p>
         </p:txBody>
@@ -9460,7 +9460,7 @@
                 </a:solidFill>
                 <a:latin typeface="Georgia"/>
               </a:rPr>
-              <a:t>nginx</a:t>
+              <a:t>Kubernetes</a:t>
             </a:r>
           </a:p>
         </p:txBody>
@@ -9500,7 +9500,7 @@
                 </a:solidFill>
                 <a:latin typeface="Arial"/>
               </a:rPr>
-              <a:t>A porta</a:t>
+              <a:t>A escala</a:t>
             </a:r>
           </a:p>
         </p:txBody>
@@ -9540,7 +9540,7 @@
                 </a:solidFill>
                 <a:latin typeface="Arial"/>
               </a:rPr>
-              <a:t>Passageiro e motorista entram por um endereço. O balanceamento do routing fica interno.</a:t>
+              <a:t>Ride e driver ficam em um pod. Matching e routing crescem quando a CPU passa de 60%.</a:t>
             </a:r>
           </a:p>
         </p:txBody>
@@ -14146,7 +14146,7 @@
                 </a:solidFill>
                 <a:latin typeface="Arial"/>
               </a:rPr>
-              <a:t>1 instância</a:t>
+              <a:t>de 1 a 3</a:t>
             </a:r>
           </a:p>
         </p:txBody>
@@ -14396,7 +14396,7 @@
                 </a:solidFill>
                 <a:latin typeface="Arial"/>
               </a:rPr>
-              <a:t>2 instâncias</a:t>
+              <a:t>de 2 a 4</a:t>
             </a:r>
           </a:p>
         </p:txBody>

</xml_diff>